<commit_message>
Add temporary presentation files for Arnav Kapil
</commit_message>
<xml_diff>
--- a/Career_Architect_AI_Bootcamp_Presentation.pptx
+++ b/Career_Architect_AI_Bootcamp_Presentation.pptx
@@ -124,12 +124,12 @@
   <p:extLst>
     <p:ext uri="{EFAFB233-063F-42B5-8137-9DF3F51BA10A}">
       <p15:sldGuideLst xmlns:p15="http://schemas.microsoft.com/office/powerpoint/2012/main">
-        <p15:guide id="1" orient="horz" pos="2168" userDrawn="1">
+        <p15:guide id="1" orient="horz" pos="2160" userDrawn="1">
           <p15:clr>
             <a:srgbClr val="A4A3A4"/>
           </p15:clr>
         </p15:guide>
-        <p15:guide id="2" pos="2880" userDrawn="1">
+        <p15:guide id="2" pos="2891" userDrawn="1">
           <p15:clr>
             <a:srgbClr val="A4A3A4"/>
           </p15:clr>
@@ -6939,8 +6939,8 @@
         </p:nvSpPr>
         <p:spPr>
           <a:xfrm>
-            <a:off x="1835696" y="2708920"/>
-            <a:ext cx="5651034" cy="1200329"/>
+            <a:off x="1649641" y="2564775"/>
+            <a:ext cx="5651034" cy="829945"/>
           </a:xfrm>
           <a:prstGeom prst="rect">
             <a:avLst/>
@@ -6953,70 +6953,55 @@
           </a:bodyPr>
           <a:lstStyle/>
           <a:p>
-            <a:r>
-              <a:t>THANK YOU</a:t>
-            </a:r>
-          </a:p>
-        </p:txBody>
-      </p:sp>
-      <p:sp>
-        <p:nvSpPr>
-          <p:cNvPr id="7" name="TextBox 6"/>
-          <p:cNvSpPr txBox="1"/>
-          <p:nvPr/>
-        </p:nvSpPr>
-        <p:spPr>
-          <a:xfrm>
-            <a:off x="2148840" y="3657600"/>
-            <a:ext cx="4846320" cy="822960"/>
-          </a:xfrm>
-          <a:prstGeom prst="rect">
-            <a:avLst/>
-          </a:prstGeom>
-          <a:noFill/>
-        </p:spPr>
-        <p:txBody>
-          <a:bodyPr wrap="square">
-            <a:spAutoFit/>
-          </a:bodyPr>
-          <a:lstStyle/>
-          <a:p>
-            <a:r>
-              <a:t>Career Architect AI</a:t>
-            </a:r>
-          </a:p>
-          <a:p>
-            <a:r>
-              <a:t>Student Bootcamp Project</a:t>
-            </a:r>
-          </a:p>
-        </p:txBody>
-      </p:sp>
-      <p:sp>
-        <p:nvSpPr>
-          <p:cNvPr id="8" name="TextBox 7"/>
-          <p:cNvSpPr txBox="1"/>
-          <p:nvPr/>
-        </p:nvSpPr>
-        <p:spPr>
-          <a:xfrm>
-            <a:off x="3520440" y="4572000"/>
-            <a:ext cx="2103120" cy="411480"/>
-          </a:xfrm>
-          <a:prstGeom prst="rect">
-            <a:avLst/>
-          </a:prstGeom>
-          <a:noFill/>
-        </p:spPr>
-        <p:txBody>
-          <a:bodyPr wrap="square">
-            <a:spAutoFit/>
-          </a:bodyPr>
-          <a:lstStyle/>
-          <a:p>
-            <a:r>
-              <a:t>Questions?</a:t>
-            </a:r>
+            <a:pPr algn="just"/>
+            <a:r>
+              <a:rPr lang="en-IN">
+                <a:latin typeface="Broadway" panose="04040905080B02020502" charset="0"/>
+                <a:cs typeface="Broadway" panose="04040905080B02020502" charset="0"/>
+              </a:rPr>
+              <a:t>                         </a:t>
+            </a:r>
+            <a:r>
+              <a:rPr lang="en-IN" sz="4800">
+                <a:latin typeface="Broadway" panose="04040905080B02020502" charset="0"/>
+                <a:cs typeface="Broadway" panose="04040905080B02020502" charset="0"/>
+              </a:rPr>
+              <a:t> </a:t>
+            </a:r>
+            <a:r>
+              <a:rPr sz="4800" b="1">
+                <a:solidFill>
+                  <a:schemeClr val="tx2"/>
+                </a:solidFill>
+                <a:latin typeface="Broadway" panose="04040905080B02020502" charset="0"/>
+                <a:cs typeface="Broadway" panose="04040905080B02020502" charset="0"/>
+              </a:rPr>
+              <a:t>THANK</a:t>
+            </a:r>
+            <a:r>
+              <a:rPr sz="4800">
+                <a:latin typeface="Broadway" panose="04040905080B02020502" charset="0"/>
+                <a:cs typeface="Broadway" panose="04040905080B02020502" charset="0"/>
+              </a:rPr>
+              <a:t> </a:t>
+            </a:r>
+            <a:r>
+              <a:rPr sz="4800" b="1">
+                <a:solidFill>
+                  <a:srgbClr val="FF0000"/>
+                </a:solidFill>
+                <a:latin typeface="Broadway" panose="04040905080B02020502" charset="0"/>
+                <a:cs typeface="Broadway" panose="04040905080B02020502" charset="0"/>
+              </a:rPr>
+              <a:t>YOU</a:t>
+            </a:r>
+            <a:endParaRPr sz="4800" b="1">
+              <a:solidFill>
+                <a:srgbClr val="FF0000"/>
+              </a:solidFill>
+              <a:latin typeface="Broadway" panose="04040905080B02020502" charset="0"/>
+              <a:cs typeface="Broadway" panose="04040905080B02020502" charset="0"/>
+            </a:endParaRPr>
           </a:p>
         </p:txBody>
       </p:sp>
@@ -7134,63 +7119,6 @@
           </a:prstGeom>
         </p:spPr>
       </p:pic>
-      <p:sp>
-        <p:nvSpPr>
-          <p:cNvPr id="13" name="TextBox 12"/>
-          <p:cNvSpPr txBox="1"/>
-          <p:nvPr/>
-        </p:nvSpPr>
-        <p:spPr>
-          <a:xfrm>
-            <a:off x="222061" y="2276169"/>
-            <a:ext cx="8784976" cy="1198880"/>
-          </a:xfrm>
-          <a:prstGeom prst="rect">
-            <a:avLst/>
-          </a:prstGeom>
-          <a:noFill/>
-        </p:spPr>
-        <p:txBody>
-          <a:bodyPr wrap="square" rtlCol="0">
-            <a:spAutoFit/>
-          </a:bodyPr>
-          <a:lstStyle/>
-          <a:p>
-            <a:r>
-              <a:rPr lang="en-IN"/>
-              <a:t>Second Year</a:t>
-            </a:r>
-          </a:p>
-          <a:p>
-            <a:r>
-              <a:t>Submitted by: </a:t>
-            </a:r>
-            <a:r>
-              <a:rPr lang="en-IN"/>
-              <a:t>Arnav Kapil</a:t>
-            </a:r>
-            <a:r>
-              <a:t> </a:t>
-            </a:r>
-          </a:p>
-          <a:p>
-            <a:r>
-              <a:rPr lang="en-IN"/>
-              <a:t>Roll.no: 2501730045</a:t>
-            </a:r>
-          </a:p>
-          <a:p>
-            <a:r>
-              <a:t>Section: </a:t>
-            </a:r>
-            <a:r>
-              <a:rPr lang="en-IN"/>
-              <a:t>  C</a:t>
-            </a:r>
-            <a:endParaRPr lang="en-IN"/>
-          </a:p>
-        </p:txBody>
-      </p:sp>
       <p:graphicFrame>
         <p:nvGraphicFramePr>
           <p:cNvPr id="2" name="Table 2"/>
@@ -7200,8 +7128,8 @@
           <p:nvPr/>
         </p:nvGraphicFramePr>
         <p:xfrm>
-          <a:off x="1670447" y="3505366"/>
-          <a:ext cx="6096000" cy="1097280"/>
+          <a:off x="1670685" y="3505200"/>
+          <a:ext cx="6096000" cy="1752600"/>
         </p:xfrm>
         <a:graphic>
           <a:graphicData uri="http://schemas.openxmlformats.org/drawingml/2006/table">
@@ -7213,15 +7141,17 @@
                 <a:gridCol w="3048000"/>
                 <a:gridCol w="3048000"/>
               </a:tblGrid>
-              <a:tr h="365760">
+              <a:tr h="438150">
                 <a:tc>
                   <a:txBody>
                     <a:bodyPr/>
                     <a:lstStyle/>
                     <a:p>
                       <a:r>
-                        <a:t>Project</a:t>
+                        <a:rPr lang="en-IN"/>
+                        <a:t>Name</a:t>
                       </a:r>
+                      <a:endParaRPr lang="en-IN"/>
                     </a:p>
                   </a:txBody>
                   <a:tcPr anchor="ctr"/>
@@ -7232,22 +7162,26 @@
                     <a:lstStyle/>
                     <a:p>
                       <a:r>
-                        <a:t>Career Architect AI</a:t>
+                        <a:rPr lang="en-IN"/>
+                        <a:t>Roll.no</a:t>
                       </a:r>
+                      <a:endParaRPr lang="en-IN"/>
                     </a:p>
                   </a:txBody>
                   <a:tcPr/>
                 </a:tc>
               </a:tr>
-              <a:tr h="365760">
+              <a:tr h="438150">
                 <a:tc>
                   <a:txBody>
                     <a:bodyPr/>
                     <a:lstStyle/>
                     <a:p>
                       <a:r>
-                        <a:t>Category</a:t>
+                        <a:rPr lang="en-IN"/>
+                        <a:t>Arnav Kapil</a:t>
                       </a:r>
+                      <a:endParaRPr lang="en-IN"/>
                     </a:p>
                   </a:txBody>
                   <a:tcPr anchor="ctr"/>
@@ -7258,22 +7192,60 @@
                     <a:lstStyle/>
                     <a:p>
                       <a:r>
-                        <a:t>Bootcamp Web Application</a:t>
+                        <a:rPr lang="en-IN"/>
+                        <a:t>2501730045</a:t>
                       </a:r>
+                      <a:endParaRPr lang="en-IN"/>
                     </a:p>
                   </a:txBody>
                   <a:tcPr anchor="ctr"/>
                 </a:tc>
               </a:tr>
-              <a:tr h="365760">
+              <a:tr h="438150">
+                <a:tc>
+                  <a:txBody>
+                    <a:bodyPr/>
+                    <a:p>
+                      <a:pPr>
+                        <a:buNone/>
+                      </a:pPr>
+                      <a:r>
+                        <a:rPr lang="en-IN"/>
+                        <a:t>Madhur Mangla</a:t>
+                      </a:r>
+                      <a:endParaRPr lang="en-IN"/>
+                    </a:p>
+                  </a:txBody>
+                  <a:tcPr anchor="ctr"/>
+                </a:tc>
+                <a:tc>
+                  <a:txBody>
+                    <a:bodyPr/>
+                    <a:p>
+                      <a:pPr>
+                        <a:buNone/>
+                      </a:pPr>
+                      <a:r>
+                        <a:rPr lang="en-IN"/>
+                        <a:t>2501350087</a:t>
+                      </a:r>
+                      <a:endParaRPr lang="en-IN"/>
+                    </a:p>
+                  </a:txBody>
+                  <a:tcPr anchor="ctr"/>
+                </a:tc>
+              </a:tr>
+              <a:tr h="438150">
                 <a:tc>
                   <a:txBody>
                     <a:bodyPr/>
                     <a:lstStyle/>
                     <a:p>
                       <a:r>
-                        <a:t>Tech Stack</a:t>
+                        <a:rPr lang="en-IN"/>
+                        <a:t>Hemant Singh Sehrawat</a:t>
                       </a:r>
+                      <a:endParaRPr lang="en-IN"/>
                     </a:p>
                   </a:txBody>
                   <a:tcPr anchor="ctr"/>
@@ -7284,8 +7256,10 @@
                     <a:lstStyle/>
                     <a:p>
                       <a:r>
-                        <a:t>HTML, CSS, JavaScript, Node.js</a:t>
+                        <a:rPr lang="en-IN"/>
+                        <a:t>2501730324</a:t>
                       </a:r>
+                      <a:endParaRPr lang="en-IN"/>
                     </a:p>
                   </a:txBody>
                   <a:tcPr anchor="ctr"/>
@@ -7352,6 +7326,7 @@
               <a:rPr lang="en-IN"/>
               <a:t>Dr. Feroz Ahmed</a:t>
             </a:r>
+            <a:endParaRPr lang="en-IN"/>
           </a:p>
           <a:p>
             <a:r>
@@ -7549,7 +7524,7 @@
         </p:nvSpPr>
         <p:spPr>
           <a:xfrm>
-            <a:off x="822960" y="1325880"/>
+            <a:off x="828040" y="2060575"/>
             <a:ext cx="7680960" cy="411480"/>
           </a:xfrm>
           <a:prstGeom prst="rect">
@@ -7577,7 +7552,7 @@
         </p:nvSpPr>
         <p:spPr>
           <a:xfrm>
-            <a:off x="822960" y="1856232"/>
+            <a:off x="822960" y="2564892"/>
             <a:ext cx="7680960" cy="411480"/>
           </a:xfrm>
           <a:prstGeom prst="rect">
@@ -7605,7 +7580,7 @@
         </p:nvSpPr>
         <p:spPr>
           <a:xfrm>
-            <a:off x="822960" y="2386584"/>
+            <a:off x="822960" y="3069209"/>
             <a:ext cx="7680960" cy="411480"/>
           </a:xfrm>
           <a:prstGeom prst="rect">
@@ -7633,8 +7608,8 @@
         </p:nvSpPr>
         <p:spPr>
           <a:xfrm>
-            <a:off x="822960" y="2916936"/>
-            <a:ext cx="7680960" cy="411480"/>
+            <a:off x="822960" y="3572256"/>
+            <a:ext cx="7680960" cy="368300"/>
           </a:xfrm>
           <a:prstGeom prst="rect">
             <a:avLst/>
@@ -7648,35 +7623,14 @@
           <a:lstStyle/>
           <a:p>
             <a:r>
-              <a:t>- Includes a resume builder with live preview and JSON export.</a:t>
-            </a:r>
-          </a:p>
-        </p:txBody>
-      </p:sp>
-      <p:sp>
-        <p:nvSpPr>
-          <p:cNvPr id="14" name="TextBox 13"/>
-          <p:cNvSpPr txBox="1"/>
-          <p:nvPr/>
-        </p:nvSpPr>
-        <p:spPr>
-          <a:xfrm>
-            <a:off x="822960" y="3447288"/>
-            <a:ext cx="7680960" cy="411480"/>
-          </a:xfrm>
-          <a:prstGeom prst="rect">
-            <a:avLst/>
-          </a:prstGeom>
-          <a:noFill/>
-        </p:spPr>
-        <p:txBody>
-          <a:bodyPr wrap="square">
-            <a:spAutoFit/>
-          </a:bodyPr>
-          <a:lstStyle/>
-          <a:p>
-            <a:r>
-              <a:t>- Designed in a simple black and white liquid glass style.</a:t>
+              <a:t>- Includes a resume builder with live preview and </a:t>
+            </a:r>
+            <a:r>
+              <a:rPr lang="en-IN"/>
+              <a:t>Dco,PDF,</a:t>
+            </a:r>
+            <a:r>
+              <a:t>JSON export.</a:t>
             </a:r>
           </a:p>
         </p:txBody>
@@ -7892,13 +7846,13 @@
       </p:sp>
       <p:sp>
         <p:nvSpPr>
-          <p:cNvPr id="10" name="TextBox 9"/>
+          <p:cNvPr id="11" name="TextBox 10"/>
           <p:cNvSpPr txBox="1"/>
           <p:nvPr/>
         </p:nvSpPr>
         <p:spPr>
           <a:xfrm>
-            <a:off x="822960" y="1325880"/>
+            <a:off x="822960" y="1856232"/>
             <a:ext cx="7680960" cy="411480"/>
           </a:xfrm>
           <a:prstGeom prst="rect">
@@ -7913,20 +7867,20 @@
           <a:lstStyle/>
           <a:p>
             <a:r>
-              <a:t>- Make a simple full stack project that is easy to explain.</a:t>
-            </a:r>
-          </a:p>
-        </p:txBody>
-      </p:sp>
-      <p:sp>
-        <p:nvSpPr>
-          <p:cNvPr id="11" name="TextBox 10"/>
+              <a:t>- Use a dataset to support resume and job role matching.</a:t>
+            </a:r>
+          </a:p>
+        </p:txBody>
+      </p:sp>
+      <p:sp>
+        <p:nvSpPr>
+          <p:cNvPr id="12" name="TextBox 11"/>
           <p:cNvSpPr txBox="1"/>
           <p:nvPr/>
         </p:nvSpPr>
         <p:spPr>
           <a:xfrm>
-            <a:off x="822960" y="1856232"/>
+            <a:off x="822960" y="2386584"/>
             <a:ext cx="7680960" cy="411480"/>
           </a:xfrm>
           <a:prstGeom prst="rect">
@@ -7941,21 +7895,21 @@
           <a:lstStyle/>
           <a:p>
             <a:r>
-              <a:t>- Use a dataset to support resume and job role matching.</a:t>
-            </a:r>
-          </a:p>
-        </p:txBody>
-      </p:sp>
-      <p:sp>
-        <p:nvSpPr>
-          <p:cNvPr id="12" name="TextBox 11"/>
+              <a:t>- Create useful APIs for analysis, metadata, and resume export.</a:t>
+            </a:r>
+          </a:p>
+        </p:txBody>
+      </p:sp>
+      <p:sp>
+        <p:nvSpPr>
+          <p:cNvPr id="13" name="TextBox 12"/>
           <p:cNvSpPr txBox="1"/>
           <p:nvPr/>
         </p:nvSpPr>
         <p:spPr>
           <a:xfrm>
-            <a:off x="822960" y="2386584"/>
-            <a:ext cx="7680960" cy="411480"/>
+            <a:off x="822960" y="2916936"/>
+            <a:ext cx="7680960" cy="368300"/>
           </a:xfrm>
           <a:prstGeom prst="rect">
             <a:avLst/>
@@ -7969,35 +7923,14 @@
           <a:lstStyle/>
           <a:p>
             <a:r>
-              <a:t>- Create useful APIs for analysis, metadata, and resume export.</a:t>
-            </a:r>
-          </a:p>
-        </p:txBody>
-      </p:sp>
-      <p:sp>
-        <p:nvSpPr>
-          <p:cNvPr id="13" name="TextBox 12"/>
-          <p:cNvSpPr txBox="1"/>
-          <p:nvPr/>
-        </p:nvSpPr>
-        <p:spPr>
-          <a:xfrm>
-            <a:off x="822960" y="2916936"/>
-            <a:ext cx="7680960" cy="411480"/>
-          </a:xfrm>
-          <a:prstGeom prst="rect">
-            <a:avLst/>
-          </a:prstGeom>
-          <a:noFill/>
-        </p:spPr>
-        <p:txBody>
-          <a:bodyPr wrap="square">
-            <a:spAutoFit/>
-          </a:bodyPr>
-          <a:lstStyle/>
-          <a:p>
-            <a:r>
-              <a:t>- Keep user resume text on the local machine.</a:t>
+              <a:t>- Keep user resume text on the local machine</a:t>
+            </a:r>
+            <a:r>
+              <a:rPr lang="en-IN"/>
+              <a:t> that Improve Privacy</a:t>
+            </a:r>
+            <a:r>
+              <a:t>.</a:t>
             </a:r>
           </a:p>
         </p:txBody>

</xml_diff>

<commit_message>
Remove temporary and backup presentation files
</commit_message>
<xml_diff>
--- a/Career_Architect_AI_Bootcamp_Presentation.pptx
+++ b/Career_Architect_AI_Bootcamp_Presentation.pptx
@@ -129,7 +129,7 @@
             <a:srgbClr val="A4A3A4"/>
           </p15:clr>
         </p15:guide>
-        <p15:guide id="2" pos="2891" userDrawn="1">
+        <p15:guide id="2" pos="2887" userDrawn="1">
           <p15:clr>
             <a:srgbClr val="A4A3A4"/>
           </p15:clr>
@@ -6011,14 +6011,14 @@
       </p:sp>
       <p:sp>
         <p:nvSpPr>
-          <p:cNvPr id="10" name="TextBox 9"/>
+          <p:cNvPr id="3" name="Text Box 2"/>
           <p:cNvSpPr txBox="1"/>
           <p:nvPr/>
         </p:nvSpPr>
         <p:spPr>
           <a:xfrm>
-            <a:off x="822960" y="1325880"/>
-            <a:ext cx="7680960" cy="411480"/>
+            <a:off x="596265" y="1456690"/>
+            <a:ext cx="7936230" cy="532130"/>
           </a:xfrm>
           <a:prstGeom prst="rect">
             <a:avLst/>
@@ -6026,27 +6026,32 @@
           <a:noFill/>
         </p:spPr>
         <p:txBody>
-          <a:bodyPr wrap="square">
-            <a:spAutoFit/>
+          <a:bodyPr wrap="square" rtlCol="0">
+            <a:noAutofit/>
           </a:bodyPr>
-          <a:lstStyle/>
-          <a:p>
-            <a:r>
-              <a:t>- Training data: 10,000 synthetic resume examples.</a:t>
-            </a:r>
-          </a:p>
-        </p:txBody>
-      </p:sp>
-      <p:sp>
-        <p:nvSpPr>
-          <p:cNvPr id="11" name="TextBox 10"/>
+          <a:p>
+            <a:r>
+              <a:rPr lang="en-IN" altLang="en-US"/>
+              <a:t>-</a:t>
+            </a:r>
+            <a:r>
+              <a:rPr lang="en-US" altLang="en-US"/>
+              <a:t>The project uses a local synthetic resume-role dataset stored in CSV and JSON files.</a:t>
+            </a:r>
+            <a:endParaRPr lang="en-US" altLang="en-US"/>
+          </a:p>
+        </p:txBody>
+      </p:sp>
+      <p:sp>
+        <p:nvSpPr>
+          <p:cNvPr id="8" name="Text Box 7"/>
           <p:cNvSpPr txBox="1"/>
           <p:nvPr/>
         </p:nvSpPr>
         <p:spPr>
           <a:xfrm>
-            <a:off x="822960" y="1856232"/>
-            <a:ext cx="7680960" cy="411480"/>
+            <a:off x="596265" y="2185035"/>
+            <a:ext cx="7703185" cy="595630"/>
           </a:xfrm>
           <a:prstGeom prst="rect">
             <a:avLst/>
@@ -6054,27 +6059,32 @@
           <a:noFill/>
         </p:spPr>
         <p:txBody>
-          <a:bodyPr wrap="square">
-            <a:spAutoFit/>
+          <a:bodyPr wrap="square" rtlCol="0">
+            <a:noAutofit/>
           </a:bodyPr>
-          <a:lstStyle/>
-          <a:p>
-            <a:r>
-              <a:t>- Job roles: 324 role labels used for recommendations.</a:t>
-            </a:r>
-          </a:p>
-        </p:txBody>
-      </p:sp>
-      <p:sp>
-        <p:nvSpPr>
-          <p:cNvPr id="12" name="TextBox 11"/>
+          <a:p>
+            <a:r>
+              <a:rPr lang="en-IN" altLang="en-US"/>
+              <a:t>-</a:t>
+            </a:r>
+            <a:r>
+              <a:rPr lang="en-US" altLang="en-US"/>
+              <a:t>Main data includes training resumes, job role profiles, skill lists, and test resume samples.</a:t>
+            </a:r>
+            <a:endParaRPr lang="en-US" altLang="en-US"/>
+          </a:p>
+        </p:txBody>
+      </p:sp>
+      <p:sp>
+        <p:nvSpPr>
+          <p:cNvPr id="15" name="Text Box 14"/>
           <p:cNvSpPr txBox="1"/>
           <p:nvPr/>
         </p:nvSpPr>
         <p:spPr>
           <a:xfrm>
-            <a:off x="822960" y="2386584"/>
-            <a:ext cx="7680960" cy="411480"/>
+            <a:off x="596265" y="2996565"/>
+            <a:ext cx="7649210" cy="598170"/>
           </a:xfrm>
           <a:prstGeom prst="rect">
             <a:avLst/>
@@ -6082,27 +6092,32 @@
           <a:noFill/>
         </p:spPr>
         <p:txBody>
-          <a:bodyPr wrap="square">
-            <a:spAutoFit/>
+          <a:bodyPr wrap="square" rtlCol="0">
+            <a:noAutofit/>
           </a:bodyPr>
-          <a:lstStyle/>
-          <a:p>
-            <a:r>
-              <a:t>- Skills list: used to find known technical and professional skills.</a:t>
-            </a:r>
-          </a:p>
-        </p:txBody>
-      </p:sp>
-      <p:sp>
-        <p:nvSpPr>
-          <p:cNvPr id="13" name="TextBox 12"/>
+          <a:p>
+            <a:r>
+              <a:rPr lang="en-IN" altLang="en-US"/>
+              <a:t>-</a:t>
+            </a:r>
+            <a:r>
+              <a:rPr lang="en-US" altLang="en-US"/>
+              <a:t>The dataset source is Kaggle: https://www.kaggle.com/datasets/trendcart/resume-dataset</a:t>
+            </a:r>
+            <a:endParaRPr lang="en-US" altLang="en-US"/>
+          </a:p>
+        </p:txBody>
+      </p:sp>
+      <p:sp>
+        <p:nvSpPr>
+          <p:cNvPr id="16" name="Text Box 15"/>
           <p:cNvSpPr txBox="1"/>
           <p:nvPr/>
         </p:nvSpPr>
         <p:spPr>
           <a:xfrm>
-            <a:off x="822960" y="2916936"/>
-            <a:ext cx="7680960" cy="411480"/>
+            <a:off x="611505" y="3932555"/>
+            <a:ext cx="7658735" cy="655955"/>
           </a:xfrm>
           <a:prstGeom prst="rect">
             <a:avLst/>
@@ -6110,27 +6125,32 @@
           <a:noFill/>
         </p:spPr>
         <p:txBody>
-          <a:bodyPr wrap="square">
-            <a:spAutoFit/>
+          <a:bodyPr wrap="square" rtlCol="0">
+            <a:noAutofit/>
           </a:bodyPr>
-          <a:lstStyle/>
-          <a:p>
-            <a:r>
-              <a:t>- Test resumes: used for simple evaluation and smoke testing.</a:t>
-            </a:r>
-          </a:p>
-        </p:txBody>
-      </p:sp>
-      <p:sp>
-        <p:nvSpPr>
-          <p:cNvPr id="14" name="TextBox 13"/>
+          <a:p>
+            <a:r>
+              <a:rPr lang="en-IN" altLang="en-US"/>
+              <a:t>-</a:t>
+            </a:r>
+            <a:r>
+              <a:rPr lang="en-US" altLang="en-US"/>
+              <a:t>The app loads the data locally, so no external API or cloud database is needed.</a:t>
+            </a:r>
+            <a:endParaRPr lang="en-US" altLang="en-US"/>
+          </a:p>
+        </p:txBody>
+      </p:sp>
+      <p:sp>
+        <p:nvSpPr>
+          <p:cNvPr id="17" name="Text Box 16"/>
           <p:cNvSpPr txBox="1"/>
           <p:nvPr/>
         </p:nvSpPr>
         <p:spPr>
           <a:xfrm>
-            <a:off x="822960" y="3447288"/>
-            <a:ext cx="7680960" cy="411480"/>
+            <a:off x="596265" y="4622800"/>
+            <a:ext cx="7640955" cy="657860"/>
           </a:xfrm>
           <a:prstGeom prst="rect">
             <a:avLst/>
@@ -6138,14 +6158,19 @@
           <a:noFill/>
         </p:spPr>
         <p:txBody>
-          <a:bodyPr wrap="square">
-            <a:spAutoFit/>
+          <a:bodyPr wrap="square" rtlCol="0">
+            <a:noAutofit/>
           </a:bodyPr>
-          <a:lstStyle/>
-          <a:p>
-            <a:r>
-              <a:t>- Report and presentation templates: used for final project submission files.</a:t>
-            </a:r>
+          <a:p>
+            <a:r>
+              <a:rPr lang="en-IN" altLang="en-US"/>
+              <a:t>-</a:t>
+            </a:r>
+            <a:r>
+              <a:rPr lang="en-US" altLang="en-US"/>
+              <a:t>Supporting resources include Node.js server code, frontend files, tests, and export templates for resume output.</a:t>
+            </a:r>
+            <a:endParaRPr lang="en-US" altLang="en-US"/>
           </a:p>
         </p:txBody>
       </p:sp>
@@ -6709,14 +6734,14 @@
       </p:sp>
       <p:sp>
         <p:nvSpPr>
-          <p:cNvPr id="10" name="TextBox 9"/>
+          <p:cNvPr id="2" name="Text Box 1"/>
           <p:cNvSpPr txBox="1"/>
           <p:nvPr/>
         </p:nvSpPr>
         <p:spPr>
           <a:xfrm>
-            <a:off x="822960" y="1325880"/>
-            <a:ext cx="7680960" cy="411480"/>
+            <a:off x="539750" y="1556385"/>
+            <a:ext cx="7220585" cy="574040"/>
           </a:xfrm>
           <a:prstGeom prst="rect">
             <a:avLst/>
@@ -6724,27 +6749,32 @@
           <a:noFill/>
         </p:spPr>
         <p:txBody>
-          <a:bodyPr wrap="square">
-            <a:spAutoFit/>
+          <a:bodyPr wrap="square" rtlCol="0">
+            <a:noAutofit/>
           </a:bodyPr>
-          <a:lstStyle/>
-          <a:p>
-            <a:r>
-              <a:t>- A working local resume analyzer and resume builder.</a:t>
-            </a:r>
-          </a:p>
-        </p:txBody>
-      </p:sp>
-      <p:sp>
-        <p:nvSpPr>
-          <p:cNvPr id="11" name="TextBox 10"/>
+          <a:p>
+            <a:r>
+              <a:rPr lang="en-IN" altLang="en-US"/>
+              <a:t>-</a:t>
+            </a:r>
+            <a:r>
+              <a:rPr lang="en-US" altLang="en-US"/>
+              <a:t>Users can quickly analyze resumes and identify skill gaps against a target job role.</a:t>
+            </a:r>
+            <a:endParaRPr lang="en-US"/>
+          </a:p>
+        </p:txBody>
+      </p:sp>
+      <p:sp>
+        <p:nvSpPr>
+          <p:cNvPr id="3" name="Text Box 2"/>
           <p:cNvSpPr txBox="1"/>
           <p:nvPr/>
         </p:nvSpPr>
         <p:spPr>
           <a:xfrm>
-            <a:off x="822960" y="1856232"/>
-            <a:ext cx="7680960" cy="411480"/>
+            <a:off x="539750" y="2336165"/>
+            <a:ext cx="7593965" cy="574040"/>
           </a:xfrm>
           <a:prstGeom prst="rect">
             <a:avLst/>
@@ -6752,27 +6782,32 @@
           <a:noFill/>
         </p:spPr>
         <p:txBody>
-          <a:bodyPr wrap="square">
-            <a:spAutoFit/>
+          <a:bodyPr wrap="square" rtlCol="0">
+            <a:noAutofit/>
           </a:bodyPr>
-          <a:lstStyle/>
-          <a:p>
-            <a:r>
-              <a:t>- Clear score, suggested roles, matched skills, and missing skills.</a:t>
-            </a:r>
-          </a:p>
-        </p:txBody>
-      </p:sp>
-      <p:sp>
-        <p:nvSpPr>
-          <p:cNvPr id="12" name="TextBox 11"/>
+          <a:p>
+            <a:r>
+              <a:rPr lang="en-IN" altLang="en-US"/>
+              <a:t>-</a:t>
+            </a:r>
+            <a:r>
+              <a:rPr lang="en-US" altLang="en-US"/>
+              <a:t>The project improves resume quality by helping users build ATS-friendly resumes.</a:t>
+            </a:r>
+            <a:endParaRPr lang="en-US" altLang="en-US"/>
+          </a:p>
+        </p:txBody>
+      </p:sp>
+      <p:sp>
+        <p:nvSpPr>
+          <p:cNvPr id="8" name="Text Box 7"/>
           <p:cNvSpPr txBox="1"/>
           <p:nvPr/>
         </p:nvSpPr>
         <p:spPr>
           <a:xfrm>
-            <a:off x="822960" y="2386584"/>
-            <a:ext cx="7680960" cy="411480"/>
+            <a:off x="539750" y="3098800"/>
+            <a:ext cx="7629525" cy="496570"/>
           </a:xfrm>
           <a:prstGeom prst="rect">
             <a:avLst/>
@@ -6780,27 +6815,32 @@
           <a:noFill/>
         </p:spPr>
         <p:txBody>
-          <a:bodyPr wrap="square">
-            <a:spAutoFit/>
+          <a:bodyPr wrap="square" rtlCol="0">
+            <a:noAutofit/>
           </a:bodyPr>
-          <a:lstStyle/>
-          <a:p>
-            <a:r>
-              <a:t>- Simpler black and white interface suitable for student submission.</a:t>
-            </a:r>
-          </a:p>
-        </p:txBody>
-      </p:sp>
-      <p:sp>
-        <p:nvSpPr>
-          <p:cNvPr id="13" name="TextBox 12"/>
+          <a:p>
+            <a:r>
+              <a:rPr lang="en-IN" altLang="en-US"/>
+              <a:t>-</a:t>
+            </a:r>
+            <a:r>
+              <a:rPr lang="en-US" altLang="en-US"/>
+              <a:t>It saves time by giving instant role suggestions, scoring, and export options.</a:t>
+            </a:r>
+            <a:endParaRPr lang="en-US" altLang="en-US"/>
+          </a:p>
+        </p:txBody>
+      </p:sp>
+      <p:sp>
+        <p:nvSpPr>
+          <p:cNvPr id="15" name="Text Box 14"/>
           <p:cNvSpPr txBox="1"/>
           <p:nvPr/>
         </p:nvSpPr>
         <p:spPr>
           <a:xfrm>
-            <a:off x="822960" y="2916936"/>
-            <a:ext cx="7680960" cy="411480"/>
+            <a:off x="539750" y="3716655"/>
+            <a:ext cx="7071995" cy="581025"/>
           </a:xfrm>
           <a:prstGeom prst="rect">
             <a:avLst/>
@@ -6808,27 +6848,32 @@
           <a:noFill/>
         </p:spPr>
         <p:txBody>
-          <a:bodyPr wrap="square">
-            <a:spAutoFit/>
+          <a:bodyPr wrap="square" rtlCol="0">
+            <a:noAutofit/>
           </a:bodyPr>
-          <a:lstStyle/>
-          <a:p>
-            <a:r>
-              <a:t>- Better understanding of full stack web development.</a:t>
-            </a:r>
-          </a:p>
-        </p:txBody>
-      </p:sp>
-      <p:sp>
-        <p:nvSpPr>
-          <p:cNvPr id="14" name="TextBox 13"/>
+          <a:p>
+            <a:r>
+              <a:rPr lang="en-IN" altLang="en-US"/>
+              <a:t>-</a:t>
+            </a:r>
+            <a:r>
+              <a:rPr lang="en-US" altLang="en-US"/>
+              <a:t>The tool makes resume improvement more structured, clear, and easier for students and job seekers.</a:t>
+            </a:r>
+            <a:endParaRPr lang="en-US"/>
+          </a:p>
+        </p:txBody>
+      </p:sp>
+      <p:sp>
+        <p:nvSpPr>
+          <p:cNvPr id="16" name="Text Box 15"/>
           <p:cNvSpPr txBox="1"/>
           <p:nvPr/>
         </p:nvSpPr>
         <p:spPr>
           <a:xfrm>
-            <a:off x="822960" y="3447288"/>
-            <a:ext cx="7680960" cy="411480"/>
+            <a:off x="539750" y="4509135"/>
+            <a:ext cx="7046595" cy="592455"/>
           </a:xfrm>
           <a:prstGeom prst="rect">
             <a:avLst/>
@@ -6836,14 +6881,23 @@
           <a:noFill/>
         </p:spPr>
         <p:txBody>
-          <a:bodyPr wrap="square">
-            <a:spAutoFit/>
+          <a:bodyPr wrap="square" rtlCol="0">
+            <a:noAutofit/>
           </a:bodyPr>
-          <a:lstStyle/>
-          <a:p>
-            <a:r>
-              <a:t>- All existing automated tests pass after implementation.</a:t>
-            </a:r>
+          <a:p>
+            <a:r>
+              <a:rPr lang="en-IN" altLang="en-US"/>
+              <a:t>-</a:t>
+            </a:r>
+            <a:r>
+              <a:rPr lang="en-US" altLang="en-US"/>
+              <a:t>Since it runs locally with explainable results, it is useful for learning and safe decision support</a:t>
+            </a:r>
+            <a:r>
+              <a:rPr lang="en-IN" altLang="en-US"/>
+              <a:t>.</a:t>
+            </a:r>
+            <a:endParaRPr lang="en-IN" altLang="en-US"/>
           </a:p>
         </p:txBody>
       </p:sp>
@@ -6939,8 +6993,8 @@
         </p:nvSpPr>
         <p:spPr>
           <a:xfrm>
-            <a:off x="1649641" y="2564775"/>
-            <a:ext cx="5651034" cy="829945"/>
+            <a:off x="1619885" y="2564765"/>
+            <a:ext cx="5650865" cy="1262380"/>
           </a:xfrm>
           <a:prstGeom prst="rect">
             <a:avLst/>
@@ -6949,53 +7003,39 @@
         </p:spPr>
         <p:txBody>
           <a:bodyPr wrap="square" rtlCol="0">
-            <a:spAutoFit/>
+            <a:noAutofit/>
           </a:bodyPr>
           <a:lstStyle/>
           <a:p>
-            <a:pPr algn="just"/>
-            <a:r>
-              <a:rPr lang="en-IN">
-                <a:latin typeface="Broadway" panose="04040905080B02020502" charset="0"/>
-                <a:cs typeface="Broadway" panose="04040905080B02020502" charset="0"/>
+            <a:pPr algn="ctr"/>
+            <a:r>
+              <a:rPr lang="en-US" sz="6000" dirty="0">
+                <a:solidFill>
+                  <a:srgbClr val="0060AA"/>
+                </a:solidFill>
+                <a:latin typeface="Garamond" panose="02020404030301010803" pitchFamily="18" charset="0"/>
+                <a:sym typeface="+mn-ea"/>
               </a:rPr>
-              <a:t>                         </a:t>
-            </a:r>
-            <a:r>
-              <a:rPr lang="en-IN" sz="4800">
-                <a:latin typeface="Broadway" panose="04040905080B02020502" charset="0"/>
-                <a:cs typeface="Broadway" panose="04040905080B02020502" charset="0"/>
+              <a:t>THANK</a:t>
+            </a:r>
+            <a:r>
+              <a:rPr lang="en-US" sz="6000" dirty="0">
+                <a:latin typeface="Garamond" panose="02020404030301010803" pitchFamily="18" charset="0"/>
+                <a:sym typeface="+mn-ea"/>
               </a:rPr>
               <a:t> </a:t>
             </a:r>
             <a:r>
-              <a:rPr sz="4800" b="1">
+              <a:rPr lang="en-US" sz="6000" dirty="0">
                 <a:solidFill>
-                  <a:schemeClr val="tx2"/>
+                  <a:srgbClr val="E31E24"/>
                 </a:solidFill>
-                <a:latin typeface="Broadway" panose="04040905080B02020502" charset="0"/>
-                <a:cs typeface="Broadway" panose="04040905080B02020502" charset="0"/>
-              </a:rPr>
-              <a:t>THANK</a:t>
-            </a:r>
-            <a:r>
-              <a:rPr sz="4800">
-                <a:latin typeface="Broadway" panose="04040905080B02020502" charset="0"/>
-                <a:cs typeface="Broadway" panose="04040905080B02020502" charset="0"/>
-              </a:rPr>
-              <a:t> </a:t>
-            </a:r>
-            <a:r>
-              <a:rPr sz="4800" b="1">
-                <a:solidFill>
-                  <a:srgbClr val="FF0000"/>
-                </a:solidFill>
-                <a:latin typeface="Broadway" panose="04040905080B02020502" charset="0"/>
-                <a:cs typeface="Broadway" panose="04040905080B02020502" charset="0"/>
+                <a:latin typeface="Garamond" panose="02020404030301010803" pitchFamily="18" charset="0"/>
+                <a:sym typeface="+mn-ea"/>
               </a:rPr>
               <a:t>YOU</a:t>
             </a:r>
-            <a:endParaRPr sz="4800" b="1">
+            <a:endParaRPr sz="6000" b="1">
               <a:solidFill>
                 <a:srgbClr val="FF0000"/>
               </a:solidFill>
@@ -7335,6 +7375,78 @@
           </a:p>
         </p:txBody>
       </p:sp>
+      <p:sp>
+        <p:nvSpPr>
+          <p:cNvPr id="3" name="Text Box 2"/>
+          <p:cNvSpPr txBox="1"/>
+          <p:nvPr/>
+        </p:nvSpPr>
+        <p:spPr>
+          <a:xfrm>
+            <a:off x="1619250" y="2381250"/>
+            <a:ext cx="5837555" cy="480695"/>
+          </a:xfrm>
+          <a:prstGeom prst="rect">
+            <a:avLst/>
+          </a:prstGeom>
+          <a:noFill/>
+        </p:spPr>
+        <p:txBody>
+          <a:bodyPr wrap="square" rtlCol="0">
+            <a:noAutofit/>
+          </a:bodyPr>
+          <a:p>
+            <a:r>
+              <a:rPr lang="en-IN" altLang="en-US" sz="2400" b="1">
+                <a:solidFill>
+                  <a:srgbClr val="006CB4"/>
+                </a:solidFill>
+                <a:uFill>
+                  <a:solidFill>
+                    <a:srgbClr val="E83030"/>
+                  </a:solidFill>
+                </a:uFill>
+              </a:rPr>
+              <a:t>FIRST YEAR</a:t>
+            </a:r>
+            <a:endParaRPr lang="en-IN" altLang="en-US" sz="2400" b="1">
+              <a:solidFill>
+                <a:srgbClr val="006CB4"/>
+              </a:solidFill>
+              <a:uFill>
+                <a:solidFill>
+                  <a:srgbClr val="E83030"/>
+                </a:solidFill>
+              </a:uFill>
+            </a:endParaRPr>
+          </a:p>
+          <a:p>
+            <a:r>
+              <a:rPr lang="en-IN" altLang="en-US" sz="2400" b="1">
+                <a:solidFill>
+                  <a:srgbClr val="006CB4"/>
+                </a:solidFill>
+                <a:uFill>
+                  <a:solidFill>
+                    <a:srgbClr val="E83030"/>
+                  </a:solidFill>
+                </a:uFill>
+              </a:rPr>
+              <a:t>SUBMITED BY:</a:t>
+            </a:r>
+            <a:endParaRPr lang="en-IN" altLang="en-US" sz="2400" b="1">
+              <a:solidFill>
+                <a:srgbClr val="006CB4"/>
+              </a:solidFill>
+              <a:uFill>
+                <a:solidFill>
+                  <a:srgbClr val="E83030"/>
+                </a:solidFill>
+              </a:uFill>
+            </a:endParaRPr>
+          </a:p>
+        </p:txBody>
+      </p:sp>
     </p:spTree>
   </p:cSld>
   <p:clrMapOvr>
@@ -7518,14 +7630,14 @@
       </p:pic>
       <p:sp>
         <p:nvSpPr>
-          <p:cNvPr id="10" name="TextBox 9"/>
+          <p:cNvPr id="2" name="Text Box 1"/>
           <p:cNvSpPr txBox="1"/>
           <p:nvPr/>
         </p:nvSpPr>
         <p:spPr>
           <a:xfrm>
-            <a:off x="828040" y="2060575"/>
-            <a:ext cx="7680960" cy="411480"/>
+            <a:off x="569595" y="1518285"/>
+            <a:ext cx="7602855" cy="533400"/>
           </a:xfrm>
           <a:prstGeom prst="rect">
             <a:avLst/>
@@ -7533,27 +7645,32 @@
           <a:noFill/>
         </p:spPr>
         <p:txBody>
-          <a:bodyPr wrap="square">
-            <a:spAutoFit/>
+          <a:bodyPr wrap="square" rtlCol="0">
+            <a:noAutofit/>
           </a:bodyPr>
-          <a:lstStyle/>
-          <a:p>
-            <a:r>
-              <a:t>- A local web app that analyzes resume text and suggests job roles.</a:t>
-            </a:r>
-          </a:p>
-        </p:txBody>
-      </p:sp>
-      <p:sp>
-        <p:nvSpPr>
-          <p:cNvPr id="11" name="TextBox 10"/>
+          <a:p>
+            <a:r>
+              <a:rPr lang="en-IN" altLang="en-US"/>
+              <a:t>-</a:t>
+            </a:r>
+            <a:r>
+              <a:rPr lang="en-US" altLang="en-US"/>
+              <a:t>Career Architect AI is a local web-based resume analyzer and resume builder</a:t>
+            </a:r>
+            <a:endParaRPr lang="en-US"/>
+          </a:p>
+        </p:txBody>
+      </p:sp>
+      <p:sp>
+        <p:nvSpPr>
+          <p:cNvPr id="3" name="Text Box 2"/>
           <p:cNvSpPr txBox="1"/>
           <p:nvPr/>
         </p:nvSpPr>
         <p:spPr>
           <a:xfrm>
-            <a:off x="822960" y="2564892"/>
-            <a:ext cx="7680960" cy="411480"/>
+            <a:off x="569595" y="2132330"/>
+            <a:ext cx="7360920" cy="504825"/>
           </a:xfrm>
           <a:prstGeom prst="rect">
             <a:avLst/>
@@ -7561,27 +7678,35 @@
           <a:noFill/>
         </p:spPr>
         <p:txBody>
-          <a:bodyPr wrap="square">
-            <a:spAutoFit/>
+          <a:bodyPr wrap="square" rtlCol="0">
+            <a:noAutofit/>
           </a:bodyPr>
-          <a:lstStyle/>
-          <a:p>
-            <a:r>
-              <a:t>- Compares a resume with an optional job description.</a:t>
-            </a:r>
-          </a:p>
-        </p:txBody>
-      </p:sp>
-      <p:sp>
-        <p:nvSpPr>
-          <p:cNvPr id="12" name="TextBox 11"/>
+          <a:p>
+            <a:r>
+              <a:rPr lang="en-IN" altLang="en-US"/>
+              <a:t>-</a:t>
+            </a:r>
+            <a:r>
+              <a:rPr lang="en-US" altLang="en-US"/>
+              <a:t>It helps users compare resumes with job descriptions and identify skill gaps.</a:t>
+            </a:r>
+            <a:endParaRPr lang="en-US" altLang="en-US"/>
+          </a:p>
+          <a:p>
+            <a:endParaRPr lang="en-US" altLang="en-US"/>
+          </a:p>
+        </p:txBody>
+      </p:sp>
+      <p:sp>
+        <p:nvSpPr>
+          <p:cNvPr id="6" name="Text Box 5"/>
           <p:cNvSpPr txBox="1"/>
           <p:nvPr/>
         </p:nvSpPr>
         <p:spPr>
           <a:xfrm>
-            <a:off x="822960" y="3069209"/>
-            <a:ext cx="7680960" cy="411480"/>
+            <a:off x="569595" y="2708910"/>
+            <a:ext cx="7496175" cy="505460"/>
           </a:xfrm>
           <a:prstGeom prst="rect">
             <a:avLst/>
@@ -7589,27 +7714,32 @@
           <a:noFill/>
         </p:spPr>
         <p:txBody>
-          <a:bodyPr wrap="square">
-            <a:spAutoFit/>
+          <a:bodyPr wrap="square" rtlCol="0">
+            <a:noAutofit/>
           </a:bodyPr>
-          <a:lstStyle/>
-          <a:p>
-            <a:r>
-              <a:t>- Shows matched skills, missing skills, score, and role recommendations.</a:t>
-            </a:r>
-          </a:p>
-        </p:txBody>
-      </p:sp>
-      <p:sp>
-        <p:nvSpPr>
-          <p:cNvPr id="13" name="TextBox 12"/>
+          <a:p>
+            <a:r>
+              <a:rPr lang="en-IN" altLang="en-US"/>
+              <a:t>-</a:t>
+            </a:r>
+            <a:r>
+              <a:rPr lang="en-US" altLang="en-US"/>
+              <a:t>The system predicts suitable job roles and gives an explainable match score.</a:t>
+            </a:r>
+            <a:endParaRPr lang="en-US" altLang="en-US"/>
+          </a:p>
+        </p:txBody>
+      </p:sp>
+      <p:sp>
+        <p:nvSpPr>
+          <p:cNvPr id="8" name="Text Box 7"/>
           <p:cNvSpPr txBox="1"/>
           <p:nvPr/>
         </p:nvSpPr>
         <p:spPr>
           <a:xfrm>
-            <a:off x="822960" y="3572256"/>
-            <a:ext cx="7680960" cy="368300"/>
+            <a:off x="569595" y="3286125"/>
+            <a:ext cx="7613650" cy="574675"/>
           </a:xfrm>
           <a:prstGeom prst="rect">
             <a:avLst/>
@@ -7617,21 +7747,19 @@
           <a:noFill/>
         </p:spPr>
         <p:txBody>
-          <a:bodyPr wrap="square">
-            <a:spAutoFit/>
+          <a:bodyPr wrap="square" rtlCol="0">
+            <a:noAutofit/>
           </a:bodyPr>
-          <a:lstStyle/>
-          <a:p>
-            <a:r>
-              <a:t>- Includes a resume builder with live preview and </a:t>
-            </a:r>
-            <a:r>
-              <a:rPr lang="en-IN"/>
-              <a:t>Dco,PDF,</a:t>
-            </a:r>
-            <a:r>
-              <a:t>JSON export.</a:t>
-            </a:r>
+          <a:p>
+            <a:r>
+              <a:rPr lang="en-IN" altLang="en-US"/>
+              <a:t>-</a:t>
+            </a:r>
+            <a:r>
+              <a:rPr lang="en-US" altLang="en-US"/>
+              <a:t>It also lets users create ATS-friendly resumes and export them as PDF, DOC, or JSON.</a:t>
+            </a:r>
+            <a:endParaRPr lang="en-US" altLang="en-US"/>
           </a:p>
         </p:txBody>
       </p:sp>
@@ -8533,7 +8661,7 @@
         </p:blipFill>
         <p:spPr>
           <a:xfrm>
-            <a:off x="1" y="0"/>
+            <a:off x="1" y="-27305"/>
             <a:ext cx="9180512" cy="6885384"/>
           </a:xfrm>
         </p:spPr>
@@ -8690,6 +8818,171 @@
             <a:r>
               <a:t> </a:t>
             </a:r>
+          </a:p>
+        </p:txBody>
+      </p:sp>
+      <p:sp>
+        <p:nvSpPr>
+          <p:cNvPr id="2" name="Text Box 1"/>
+          <p:cNvSpPr txBox="1"/>
+          <p:nvPr/>
+        </p:nvSpPr>
+        <p:spPr>
+          <a:xfrm>
+            <a:off x="467995" y="1628775"/>
+            <a:ext cx="7723505" cy="558165"/>
+          </a:xfrm>
+          <a:prstGeom prst="rect">
+            <a:avLst/>
+          </a:prstGeom>
+          <a:noFill/>
+        </p:spPr>
+        <p:txBody>
+          <a:bodyPr wrap="square" rtlCol="0">
+            <a:noAutofit/>
+          </a:bodyPr>
+          <a:p>
+            <a:r>
+              <a:rPr lang="en-IN" altLang="en-US"/>
+              <a:t>-</a:t>
+            </a:r>
+            <a:r>
+              <a:rPr lang="en-US" altLang="en-US"/>
+              <a:t>Career Architect AI is a local resume analysis and resume-building web app.</a:t>
+            </a:r>
+            <a:endParaRPr lang="en-US" altLang="en-US"/>
+          </a:p>
+        </p:txBody>
+      </p:sp>
+      <p:sp>
+        <p:nvSpPr>
+          <p:cNvPr id="3" name="Text Box 2"/>
+          <p:cNvSpPr txBox="1"/>
+          <p:nvPr/>
+        </p:nvSpPr>
+        <p:spPr>
+          <a:xfrm>
+            <a:off x="467995" y="2131695"/>
+            <a:ext cx="7776845" cy="487045"/>
+          </a:xfrm>
+          <a:prstGeom prst="rect">
+            <a:avLst/>
+          </a:prstGeom>
+          <a:noFill/>
+        </p:spPr>
+        <p:txBody>
+          <a:bodyPr wrap="square" rtlCol="0">
+            <a:noAutofit/>
+          </a:bodyPr>
+          <a:p>
+            <a:r>
+              <a:rPr lang="en-IN" altLang="en-US"/>
+              <a:t>-</a:t>
+            </a:r>
+            <a:r>
+              <a:rPr lang="en-US" altLang="en-US"/>
+              <a:t>It compares resumes with job descriptions and shows matched and missing skills.</a:t>
+            </a:r>
+            <a:endParaRPr lang="en-US" altLang="en-US"/>
+          </a:p>
+        </p:txBody>
+      </p:sp>
+      <p:sp>
+        <p:nvSpPr>
+          <p:cNvPr id="8" name="Text Box 7"/>
+          <p:cNvSpPr txBox="1"/>
+          <p:nvPr/>
+        </p:nvSpPr>
+        <p:spPr>
+          <a:xfrm>
+            <a:off x="467995" y="2753995"/>
+            <a:ext cx="7589520" cy="568325"/>
+          </a:xfrm>
+          <a:prstGeom prst="rect">
+            <a:avLst/>
+          </a:prstGeom>
+          <a:noFill/>
+        </p:spPr>
+        <p:txBody>
+          <a:bodyPr wrap="square" rtlCol="0">
+            <a:noAutofit/>
+          </a:bodyPr>
+          <a:p>
+            <a:r>
+              <a:rPr lang="en-IN" altLang="en-US"/>
+              <a:t>-</a:t>
+            </a:r>
+            <a:r>
+              <a:rPr lang="en-US" altLang="en-US"/>
+              <a:t>It predicts suitable job roles and gives an explainable score for fit.</a:t>
+            </a:r>
+            <a:endParaRPr lang="en-US"/>
+          </a:p>
+        </p:txBody>
+      </p:sp>
+      <p:sp>
+        <p:nvSpPr>
+          <p:cNvPr id="10" name="Text Box 9"/>
+          <p:cNvSpPr txBox="1"/>
+          <p:nvPr/>
+        </p:nvSpPr>
+        <p:spPr>
+          <a:xfrm>
+            <a:off x="467995" y="3429000"/>
+            <a:ext cx="7454265" cy="514985"/>
+          </a:xfrm>
+          <a:prstGeom prst="rect">
+            <a:avLst/>
+          </a:prstGeom>
+          <a:noFill/>
+        </p:spPr>
+        <p:txBody>
+          <a:bodyPr wrap="square" rtlCol="0">
+            <a:noAutofit/>
+          </a:bodyPr>
+          <a:p>
+            <a:r>
+              <a:rPr lang="en-IN" altLang="en-US"/>
+              <a:t>-</a:t>
+            </a:r>
+            <a:r>
+              <a:rPr lang="en-US" altLang="en-US"/>
+              <a:t>It also helps users build ATS-friendly resumes and export them as PDF, DOC, or JSON.</a:t>
+            </a:r>
+            <a:endParaRPr lang="en-US" altLang="en-US"/>
+          </a:p>
+        </p:txBody>
+      </p:sp>
+      <p:sp>
+        <p:nvSpPr>
+          <p:cNvPr id="11" name="Text Box 10"/>
+          <p:cNvSpPr txBox="1"/>
+          <p:nvPr/>
+        </p:nvSpPr>
+        <p:spPr>
+          <a:xfrm>
+            <a:off x="467995" y="4161155"/>
+            <a:ext cx="7176135" cy="606425"/>
+          </a:xfrm>
+          <a:prstGeom prst="rect">
+            <a:avLst/>
+          </a:prstGeom>
+          <a:noFill/>
+        </p:spPr>
+        <p:txBody>
+          <a:bodyPr wrap="square" rtlCol="0">
+            <a:noAutofit/>
+          </a:bodyPr>
+          <a:p>
+            <a:r>
+              <a:rPr lang="en-IN" altLang="en-US"/>
+              <a:t>-T</a:t>
+            </a:r>
+            <a:r>
+              <a:rPr lang="en-US" altLang="en-US"/>
+              <a:t>he project is built with HTML, CSS, JavaScript, and a simple Node.js backend.</a:t>
+            </a:r>
+            <a:endParaRPr lang="en-US" altLang="en-US"/>
           </a:p>
         </p:txBody>
       </p:sp>
@@ -10599,6 +10892,21 @@
       </a:bgFillStyleLst>
     </a:fmtScheme>
   </a:themeElements>
+  <a:objectDefaults>
+    <a:txDef>
+      <a:spPr>
+        <a:noFill/>
+      </a:spPr>
+      <a:bodyPr wrap="square" rtlCol="0">
+        <a:noAutofit/>
+      </a:bodyPr>
+      <a:lstStyle>
+        <a:defPPr>
+          <a:defRPr lang="en-US"/>
+        </a:defPPr>
+      </a:lstStyle>
+    </a:txDef>
+  </a:objectDefaults>
   <a:extLst>
     <a:ext uri="{05A4C25C-085E-4340-85A3-A5531E510DB2}">
       <thm15:themeFamily xmlns:thm15="http://schemas.microsoft.com/office/thememl/2012/main" name="Office Theme" id="{62F939B6-93AF-4DB8-9C6B-D6C7DFDC589F}" vid="{4A3C46E8-61CC-4603-A589-7422A47A8E4A}"/>

</xml_diff>